<commit_message>
docs(mib-pack): drop the zero-cost claim — the MIB takes a share of the IB's rebate
"Free / costs you nothing" was false: MMFX is compensated out of the sub-IB's
per-lot rate. Removes the pricing section from the IB one-pager entirely and
replaces "free to the IB" with accurate framing (no fee or subscription, funded
from the per-lot pool) in the offer doc and the deck.

Co-Authored-By: Claude Opus 5 <noreply@anthropic.com>
</commit_message>
<xml_diff>
--- a/mib-pack/MMFX-Dupoin-MIB-Deck.pptx
+++ b/mib-pack/MMFX-Dupoin-MIB-Deck.pptx
@@ -2665,7 +2665,7 @@
                 <a:ea typeface="Calibri" pitchFamily="34" charset="-122"/>
                 <a:cs typeface="Calibri" pitchFamily="34" charset="-120"/>
               </a:rPr>
-              <a:t>Free to the IB</a:t>
+              <a:t>No fee, no subscription</a:t>
             </a:r>
             <a:endParaRPr lang="en-US" sz="1200" dirty="0"/>
           </a:p>
@@ -9527,7 +9527,7 @@
                 <a:ea typeface="Arial" pitchFamily="34" charset="-122"/>
                 <a:cs typeface="Arial" pitchFamily="34" charset="-120"/>
               </a:rPr>
-              <a:t>COST TO THE IB</a:t>
+              <a:t>THE IB PAYS</a:t>
             </a:r>
             <a:endParaRPr lang="en-US" sz="900" dirty="0"/>
           </a:p>
@@ -9566,7 +9566,7 @@
                 <a:ea typeface="Arial" pitchFamily="34" charset="-122"/>
                 <a:cs typeface="Arial" pitchFamily="34" charset="-120"/>
               </a:rPr>
-              <a:t>Zero</a:t>
+              <a:t>No fee</a:t>
             </a:r>
             <a:endParaRPr lang="en-US" sz="2200" dirty="0"/>
           </a:p>
@@ -9639,7 +9639,7 @@
                 <a:ea typeface="Arial" pitchFamily="34" charset="-122"/>
                 <a:cs typeface="Arial" pitchFamily="34" charset="-120"/>
               </a:rPr>
-              <a:t>COST TO DUPOIN</a:t>
+              <a:t>FUNDED FROM</a:t>
             </a:r>
             <a:endParaRPr lang="en-US" sz="900" dirty="0"/>
           </a:p>
@@ -9678,7 +9678,7 @@
                 <a:ea typeface="Arial" pitchFamily="34" charset="-122"/>
                 <a:cs typeface="Arial" pitchFamily="34" charset="-120"/>
               </a:rPr>
-              <a:t>Zero</a:t>
+              <a:t>The per-lot pool</a:t>
             </a:r>
             <a:endParaRPr lang="en-US" sz="2200" dirty="0"/>
           </a:p>
@@ -9751,7 +9751,7 @@
                 <a:ea typeface="Arial" pitchFamily="34" charset="-122"/>
                 <a:cs typeface="Arial" pitchFamily="34" charset="-120"/>
               </a:rPr>
-              <a:t>MMFX IS PAID</a:t>
+              <a:t>MMFX EARNS</a:t>
             </a:r>
             <a:endParaRPr lang="en-US" sz="900" dirty="0"/>
           </a:p>
@@ -9790,7 +9790,7 @@
                 <a:ea typeface="Arial" pitchFamily="34" charset="-122"/>
                 <a:cs typeface="Arial" pitchFamily="34" charset="-120"/>
               </a:rPr>
-              <a:t>Per lot, on volume</a:t>
+              <a:t>On volume</a:t>
             </a:r>
             <a:endParaRPr lang="en-US" sz="2200" dirty="0"/>
           </a:p>

</xml_diff>